<commit_message>
docs(v6.1): update SRS/pptx/drawio with implemented Batches 1-4
- SRS: §17 Implementation Update (batch summary, new tables/endpoints,
  D-03 dbo-write decision, latest FR status) + bump cover/footer to v6.1
  + revision row 6.1
- pptx: + slide 18 "Implementation Update — Batch 1-4" + bump v6.1 (18 slides)
- drawio: + page "2d. Implemented v6.1" (batch status) (11 pages)

Co-Authored-By: Claude Opus 4.8 <noreply@anthropic.com>
</commit_message>
<xml_diff>
--- a/refs/WorldFert_Presentation_v6.pptx
+++ b/refs/WorldFert_Presentation_v6.pptx
@@ -22,6 +22,7 @@
     <p:sldId id="270" r:id="rId21"/>
     <p:sldId id="271" r:id="rId22"/>
     <p:sldId id="272" r:id="rId23"/>
+    <p:sldId id="273" r:id="rId24"/>
   </p:sldIdLst>
   <p:notesMasterIdLst>
     <p:notesMasterId r:id="rId15"/>
@@ -2186,7 +2187,7 @@
                 <a:ea typeface="Prompt" pitchFamily="34" charset="-122"/>
                 <a:cs typeface="Prompt" pitchFamily="34" charset="-120"/>
               </a:rPr>
-              <a:t>v6.0 (Production)  ·  27 มิถุนายน 2569  ·  React 19 + Express + SQL Server (msnodesqlv8)</a:t>
+              <a:t>v6.1 (Production)  ·  27 มิถุนายน 2569  ·  React 19 + Express + SQL Server (msnodesqlv8)</a:t>
             </a:r>
             <a:endParaRPr lang="en-US" sz="1100" dirty="0"/>
           </a:p>
@@ -7912,7 +7913,7 @@
                 <a:ea typeface="Prompt" pitchFamily="34" charset="-122"/>
                 <a:cs typeface="Prompt" pitchFamily="34" charset="-120"/>
               </a:rPr>
-              <a:t>Traceability + สถานะการพัฒนา — v6.0</a:t>
+              <a:t>Traceability + สถานะการพัฒนา — v6.1</a:t>
             </a:r>
             <a:endParaRPr lang="en-US" sz="1300" dirty="0"/>
           </a:p>
@@ -10289,7 +10290,7 @@
                 <a:ea typeface="Prompt" pitchFamily="34" charset="-122"/>
                 <a:cs typeface="Prompt" pitchFamily="34" charset="-120"/>
               </a:rPr>
-              <a:t>World Fert Co., Ltd.  ·  WS-Sale-App v6.0 (Production)  ·  27 มิ.ย. 2569  ·  ข้อมูลยืนยันจาก query DB จริง  |  dbo = READ-ONLY  |  schema wf = สร้างใหม่</a:t>
+              <a:t>World Fert Co., Ltd.  ·  WS-Sale-App v6.1 (Production)  ·  27 มิ.ย. 2569  ·  ข้อมูลยืนยันจาก query DB จริง  |  dbo = READ-ONLY  |  schema wf = สร้างใหม่</a:t>
             </a:r>
             <a:endParaRPr lang="en-US" sz="850" dirty="0"/>
           </a:p>
@@ -10363,7 +10364,7 @@
                 <a:latin typeface="Prompt"/>
                 <a:cs typeface="Prompt"/>
               </a:rPr>
-              <a:t>v6.0 Release — โมดูลใหม่ &amp; สถานะการพัฒนา</a:t>
+              <a:t>v6.1 Release — โมดูลใหม่ &amp; สถานะการพัฒนา</a:t>
             </a:r>
           </a:p>
         </p:txBody>
@@ -10718,7 +10719,7 @@
                 <a:latin typeface="Prompt"/>
                 <a:cs typeface="Prompt"/>
               </a:rPr>
-              <a:t>World Fert Co., Ltd. · WS-Sale-App v6.0 (Production) · dbo = READ-ONLY · เขียนเฉพาะ schema wf</a:t>
+              <a:t>World Fert Co., Ltd. · WS-Sale-App v6.1 (Production) · dbo = READ-ONLY · เขียนเฉพาะ schema wf</a:t>
             </a:r>
           </a:p>
         </p:txBody>
@@ -10830,7 +10831,7 @@
                 <a:latin typeface="Prompt"/>
                 <a:cs typeface="Prompt"/>
               </a:rPr>
-              <a:t>แยกระบบให้ชัดเจน ไม่ปะปนกัน — ยืนยันจากข้อมูลจริง (v6.0)</a:t>
+              <a:t>แยกระบบให้ชัดเจน ไม่ปะปนกัน — ยืนยันจากข้อมูลจริง (v6.1)</a:t>
             </a:r>
           </a:p>
         </p:txBody>
@@ -12129,6 +12130,397 @@
 </p:sld>
 </file>
 
+<file path=ppt/slides/slide18.xml><?xml version="1.0" encoding="utf-8"?>
+<p:sld xmlns:a="http://schemas.openxmlformats.org/drawingml/2006/main" xmlns:r="http://schemas.openxmlformats.org/officeDocument/2006/relationships" xmlns:p="http://schemas.openxmlformats.org/presentationml/2006/main">
+  <p:cSld>
+    <p:bg>
+      <p:bgPr>
+        <a:solidFill>
+          <a:srgbClr val="F1EFE8"/>
+        </a:solidFill>
+      </p:bgPr>
+    </p:bg>
+    <p:spTree>
+      <p:nvGrpSpPr>
+        <p:cNvPr id="1" name=""/>
+        <p:cNvGrpSpPr/>
+        <p:nvPr/>
+      </p:nvGrpSpPr>
+      <p:grpSpPr>
+        <a:xfrm>
+          <a:off x="0" y="0"/>
+          <a:ext cx="0" cy="0"/>
+          <a:chOff x="0" y="0"/>
+          <a:chExt cx="0" cy="0"/>
+        </a:xfrm>
+      </p:grpSpPr>
+      <p:sp>
+        <p:nvSpPr>
+          <p:cNvPr id="17" name="b18"/>
+          <p:cNvSpPr/>
+          <p:nvPr/>
+        </p:nvSpPr>
+        <p:spPr>
+          <a:xfrm>
+            <a:off x="0" y="0"/>
+            <a:ext cx="9144000" cy="502920"/>
+          </a:xfrm>
+          <a:prstGeom prst="rect">
+            <a:avLst/>
+          </a:prstGeom>
+          <a:solidFill>
+            <a:srgbClr val="0C447C"/>
+          </a:solidFill>
+          <a:ln>
+            <a:noFill/>
+          </a:ln>
+        </p:spPr>
+        <p:txBody>
+          <a:bodyPr wrap="square" lIns="91440" tIns="45720" rIns="91440" bIns="45720" anchor="ctr">
+            <a:normAutofit/>
+          </a:bodyPr>
+          <a:lstStyle/>
+          <a:p>
+            <a:pPr/>
+            <a:r>
+              <a:rPr lang="th-TH" sz="1900" b="1" dirty="0">
+                <a:solidFill>
+                  <a:srgbClr val="FFFFFF"/>
+                </a:solidFill>
+                <a:latin typeface="Prompt"/>
+                <a:cs typeface="Prompt"/>
+              </a:rPr>
+              <a:t>Implementation Update — Batch 1-4 (build v4.2.16)</a:t>
+            </a:r>
+          </a:p>
+        </p:txBody>
+      </p:sp>
+      <p:sp>
+        <p:nvSpPr>
+          <p:cNvPr id="19" name="b20"/>
+          <p:cNvSpPr/>
+          <p:nvPr/>
+        </p:nvSpPr>
+        <p:spPr>
+          <a:xfrm>
+            <a:off x="228600" y="548640"/>
+            <a:ext cx="8686800" cy="300000"/>
+          </a:xfrm>
+          <a:prstGeom prst="rect">
+            <a:avLst/>
+          </a:prstGeom>
+          <a:noFill/>
+          <a:ln>
+            <a:noFill/>
+          </a:ln>
+        </p:spPr>
+        <p:txBody>
+          <a:bodyPr wrap="square" lIns="91440" tIns="45720" rIns="91440" bIns="45720" anchor="t">
+            <a:normAutofit/>
+          </a:bodyPr>
+          <a:lstStyle/>
+          <a:p>
+            <a:pPr/>
+            <a:r>
+              <a:rPr lang="th-TH" sz="1150" dirty="0">
+                <a:solidFill>
+                  <a:srgbClr val="5A6470"/>
+                </a:solidFill>
+                <a:latin typeface="Prompt"/>
+                <a:cs typeface="Prompt"/>
+              </a:rPr>
+              <a:t>ฟีเจอร์ที่ออกแบบไว้ → สร้างจริง + deploy (Railway + Vercel) · migration clean local+remote</a:t>
+            </a:r>
+          </a:p>
+        </p:txBody>
+      </p:sp>
+      <p:sp>
+        <p:nvSpPr>
+          <p:cNvPr id="11" name="b12"/>
+          <p:cNvSpPr/>
+          <p:nvPr/>
+        </p:nvSpPr>
+        <p:spPr>
+          <a:xfrm>
+            <a:off x="228600" y="1000000"/>
+            <a:ext cx="4500000" cy="2750000"/>
+          </a:xfrm>
+          <a:prstGeom prst="rect">
+            <a:avLst/>
+          </a:prstGeom>
+          <a:solidFill>
+            <a:srgbClr val="FFFFFF"/>
+          </a:solidFill>
+          <a:ln>
+            <a:noFill/>
+          </a:ln>
+        </p:spPr>
+        <p:txBody>
+          <a:bodyPr wrap="square" lIns="91440" tIns="45720" rIns="91440" bIns="45720" anchor="t">
+            <a:normAutofit/>
+          </a:bodyPr>
+          <a:lstStyle/>
+          <a:p>
+            <a:pPr/>
+            <a:r>
+              <a:rPr lang="th-TH" sz="1300" b="1" dirty="0">
+                <a:solidFill>
+                  <a:srgbClr val="3B6D11"/>
+                </a:solidFill>
+                <a:latin typeface="Prompt"/>
+                <a:cs typeface="Prompt"/>
+              </a:rPr>
+              <a:t>Batch ที่ deploy แล้ว</a:t>
+            </a:r>
+          </a:p>
+          <a:p>
+            <a:pPr/>
+            <a:r>
+              <a:rPr lang="th-TH" sz="1050" dirty="0">
+                <a:solidFill>
+                  <a:srgbClr val="2B2B2B"/>
+                </a:solidFill>
+                <a:latin typeface="Prompt"/>
+                <a:cs typeface="Prompt"/>
+              </a:rPr>
+              <a:t>✓ B1 — Paper Trail 4 สี + QR + scan + alert ใบหาย</a:t>
+            </a:r>
+          </a:p>
+          <a:p>
+            <a:pPr/>
+            <a:r>
+              <a:rPr lang="th-TH" sz="1050" dirty="0">
+                <a:solidFill>
+                  <a:srgbClr val="2B2B2B"/>
+                </a:solidFill>
+                <a:latin typeface="Prompt"/>
+                <a:cs typeface="Prompt"/>
+              </a:rPr>
+              <a:t>✓ B2 — Rebate Plan + จัดสรร Pool ตามภาค</a:t>
+            </a:r>
+          </a:p>
+          <a:p>
+            <a:pPr/>
+            <a:r>
+              <a:rPr lang="th-TH" sz="1050" dirty="0">
+                <a:solidFill>
+                  <a:srgbClr val="2B2B2B"/>
+                </a:solidFill>
+                <a:latin typeface="Prompt"/>
+                <a:cs typeface="Prompt"/>
+              </a:rPr>
+              <a:t>✓ B3 — Verification Gate + Unlock Request</a:t>
+            </a:r>
+          </a:p>
+          <a:p>
+            <a:pPr/>
+            <a:r>
+              <a:rPr lang="th-TH" sz="1050" dirty="0">
+                <a:solidFill>
+                  <a:srgbClr val="2B2B2B"/>
+                </a:solidFill>
+                <a:latin typeface="Prompt"/>
+                <a:cs typeface="Prompt"/>
+              </a:rPr>
+              <a:t>✓ B4a — WeighTicket (gross/tare/net + เครื่องชั่ง)</a:t>
+            </a:r>
+          </a:p>
+          <a:p>
+            <a:pPr/>
+            <a:r>
+              <a:rPr lang="th-TH" sz="1050" dirty="0">
+                <a:solidFill>
+                  <a:srgbClr val="2B2B2B"/>
+                </a:solidFill>
+                <a:latin typeface="Prompt"/>
+                <a:cs typeface="Prompt"/>
+              </a:rPr>
+              <a:t>✓ B4b — Control Ticket + Reports + Export Excel</a:t>
+            </a:r>
+          </a:p>
+          <a:p>
+            <a:pPr/>
+            <a:r>
+              <a:rPr lang="th-TH" sz="1050" dirty="0">
+                <a:solidFill>
+                  <a:srgbClr val="2B2B2B"/>
+                </a:solidFill>
+                <a:latin typeface="Prompt"/>
+                <a:cs typeface="Prompt"/>
+              </a:rPr>
+              <a:t>⏳ B4c — TruckScale live (รอ VPN 192.168.1.253)</a:t>
+            </a:r>
+          </a:p>
+        </p:txBody>
+      </p:sp>
+      <p:sp>
+        <p:nvSpPr>
+          <p:cNvPr id="13" name="b14"/>
+          <p:cNvSpPr/>
+          <p:nvPr/>
+        </p:nvSpPr>
+        <p:spPr>
+          <a:xfrm>
+            <a:off x="4850000" y="1000000"/>
+            <a:ext cx="4060000" cy="2750000"/>
+          </a:xfrm>
+          <a:prstGeom prst="rect">
+            <a:avLst/>
+          </a:prstGeom>
+          <a:solidFill>
+            <a:srgbClr val="FFFFFF"/>
+          </a:solidFill>
+          <a:ln>
+            <a:noFill/>
+          </a:ln>
+        </p:spPr>
+        <p:txBody>
+          <a:bodyPr wrap="square" lIns="91440" tIns="45720" rIns="91440" bIns="45720" anchor="t">
+            <a:normAutofit/>
+          </a:bodyPr>
+          <a:lstStyle/>
+          <a:p>
+            <a:pPr/>
+            <a:r>
+              <a:rPr lang="th-TH" sz="1300" b="1" dirty="0">
+                <a:solidFill>
+                  <a:srgbClr val="1F3864"/>
+                </a:solidFill>
+                <a:latin typeface="Prompt"/>
+                <a:cs typeface="Prompt"/>
+              </a:rPr>
+              <a:t>ของใหม่ + การตัดสินใจ</a:t>
+            </a:r>
+          </a:p>
+          <a:p>
+            <a:pPr/>
+            <a:r>
+              <a:rPr lang="th-TH" sz="1050" dirty="0">
+                <a:solidFill>
+                  <a:srgbClr val="2B2B2B"/>
+                </a:solidFill>
+                <a:latin typeface="Prompt"/>
+                <a:cs typeface="Prompt"/>
+              </a:rPr>
+              <a:t>migration 016-019:</a:t>
+            </a:r>
+          </a:p>
+          <a:p>
+            <a:pPr/>
+            <a:r>
+              <a:rPr lang="th-TH" sz="1050" dirty="0">
+                <a:solidFill>
+                  <a:srgbClr val="2B2B2B"/>
+                </a:solidFill>
+                <a:latin typeface="Prompt"/>
+                <a:cs typeface="Prompt"/>
+              </a:rPr>
+              <a:t>  PaperCopy/Scan · RebatePlan</a:t>
+            </a:r>
+          </a:p>
+          <a:p>
+            <a:pPr/>
+            <a:r>
+              <a:rPr lang="th-TH" sz="1050" dirty="0">
+                <a:solidFill>
+                  <a:srgbClr val="2B2B2B"/>
+                </a:solidFill>
+                <a:latin typeface="Prompt"/>
+                <a:cs typeface="Prompt"/>
+              </a:rPr>
+              <a:t>  UnlockRequest · WeighTicket</a:t>
+            </a:r>
+          </a:p>
+          <a:p>
+            <a:pPr/>
+            <a:r>
+              <a:rPr lang="th-TH" sz="1050" dirty="0">
+                <a:solidFill>
+                  <a:srgbClr val="2B2B2B"/>
+                </a:solidFill>
+                <a:latin typeface="Prompt"/>
+                <a:cs typeface="Prompt"/>
+              </a:rPr>
+              <a:t>dbo write ตรง (GL ยังให้ WINSpeed post)</a:t>
+            </a:r>
+          </a:p>
+          <a:p>
+            <a:pPr/>
+            <a:r>
+              <a:rPr lang="th-TH" sz="1050" dirty="0">
+                <a:solidFill>
+                  <a:srgbClr val="2B2B2B"/>
+                </a:solidFill>
+                <a:latin typeface="Prompt"/>
+                <a:cs typeface="Prompt"/>
+              </a:rPr>
+              <a:t>FR-004/006/007/008/009/</a:t>
+            </a:r>
+          </a:p>
+          <a:p>
+            <a:pPr/>
+            <a:r>
+              <a:rPr lang="th-TH" sz="1050" dirty="0">
+                <a:solidFill>
+                  <a:srgbClr val="2B2B2B"/>
+                </a:solidFill>
+                <a:latin typeface="Prompt"/>
+                <a:cs typeface="Prompt"/>
+              </a:rPr>
+              <a:t>012/013/017/021/022 = ✓</a:t>
+            </a:r>
+          </a:p>
+        </p:txBody>
+      </p:sp>
+      <p:sp>
+        <p:nvSpPr>
+          <p:cNvPr id="15" name="b16"/>
+          <p:cNvSpPr/>
+          <p:nvPr/>
+        </p:nvSpPr>
+        <p:spPr>
+          <a:xfrm>
+            <a:off x="228600" y="3900000"/>
+            <a:ext cx="8686800" cy="520000"/>
+          </a:xfrm>
+          <a:prstGeom prst="rect">
+            <a:avLst/>
+          </a:prstGeom>
+          <a:solidFill>
+            <a:srgbClr val="FFF7E6"/>
+          </a:solidFill>
+          <a:ln>
+            <a:noFill/>
+          </a:ln>
+        </p:spPr>
+        <p:txBody>
+          <a:bodyPr wrap="square" lIns="91440" tIns="45720" rIns="91440" bIns="45720" anchor="t">
+            <a:normAutofit/>
+          </a:bodyPr>
+          <a:lstStyle/>
+          <a:p>
+            <a:pPr/>
+            <a:r>
+              <a:rPr lang="th-TH" sz="1100" dirty="0">
+                <a:solidFill>
+                  <a:srgbClr val="7A4E10"/>
+                </a:solidFill>
+                <a:latin typeface="Prompt"/>
+                <a:cs typeface="Prompt"/>
+              </a:rPr>
+              <a:t>คงเหลือ: TruckScale live (รอ VPN) · รายละเอียดอ้างอิง SRS v6.1 §17 (Implementation Update)</a:t>
+            </a:r>
+          </a:p>
+        </p:txBody>
+      </p:sp>
+    </p:spTree>
+  </p:cSld>
+  <p:clrMapOvr>
+    <a:masterClrMapping/>
+  </p:clrMapOvr>
+</p:sld>
+</file>
+
 <file path=ppt/slides/slide2.xml><?xml version="1.0" encoding="utf-8"?>
 <p:sld xmlns:a="http://schemas.openxmlformats.org/drawingml/2006/main" xmlns:r="http://schemas.openxmlformats.org/officeDocument/2006/relationships" xmlns:p="http://schemas.openxmlformats.org/presentationml/2006/main">
   <p:cSld name="Slide 2">
@@ -17402,7 +17794,7 @@
                 <a:ea typeface="Prompt" pitchFamily="34" charset="-122"/>
                 <a:cs typeface="Prompt" pitchFamily="34" charset="-120"/>
               </a:rPr>
-              <a:t>UI/UX Design System — Light Theme Standard v6.0</a:t>
+              <a:t>UI/UX Design System — Light Theme Standard v6.1</a:t>
             </a:r>
             <a:endParaRPr lang="en-US" sz="1300" dirty="0"/>
           </a:p>

</xml_diff>

<commit_message>
docs(v6.2): TruckScale DESIGN → LIVE (Railway MySQL, build v4.2.17)
- SRS: §18 TruckScale Live Integration (connection, endpoints, plate-based
  matching, flow) + bump cover/footer v6.2 + revision row 6.2
- pptx: v6.1→v6.2 + TruckScale slides DESIGN→LIVE
- drawio: TruckScale page + implemented page marked LIVE

Co-Authored-By: Claude Opus 4.8 <noreply@anthropic.com>
</commit_message>
<xml_diff>
--- a/refs/WorldFert_Presentation_v6.pptx
+++ b/refs/WorldFert_Presentation_v6.pptx
@@ -2187,7 +2187,7 @@
                 <a:ea typeface="Prompt" pitchFamily="34" charset="-122"/>
                 <a:cs typeface="Prompt" pitchFamily="34" charset="-120"/>
               </a:rPr>
-              <a:t>v6.1 (Production)  ·  27 มิถุนายน 2569  ·  React 19 + Express + SQL Server (msnodesqlv8)</a:t>
+              <a:t>v6.2 (Production)  ·  27 มิถุนายน 2569  ·  React 19 + Express + SQL Server (msnodesqlv8)</a:t>
             </a:r>
             <a:endParaRPr lang="en-US" sz="1100" dirty="0"/>
           </a:p>
@@ -7913,7 +7913,7 @@
                 <a:ea typeface="Prompt" pitchFamily="34" charset="-122"/>
                 <a:cs typeface="Prompt" pitchFamily="34" charset="-120"/>
               </a:rPr>
-              <a:t>Traceability + สถานะการพัฒนา — v6.1</a:t>
+              <a:t>Traceability + สถานะการพัฒนา — v6.2</a:t>
             </a:r>
             <a:endParaRPr lang="en-US" sz="1300" dirty="0"/>
           </a:p>
@@ -10290,7 +10290,7 @@
                 <a:ea typeface="Prompt" pitchFamily="34" charset="-122"/>
                 <a:cs typeface="Prompt" pitchFamily="34" charset="-120"/>
               </a:rPr>
-              <a:t>World Fert Co., Ltd.  ·  WS-Sale-App v6.1 (Production)  ·  27 มิ.ย. 2569  ·  ข้อมูลยืนยันจาก query DB จริง  |  dbo = READ-ONLY  |  schema wf = สร้างใหม่</a:t>
+              <a:t>World Fert Co., Ltd.  ·  WS-Sale-App v6.2 (Production)  ·  27 มิ.ย. 2569  ·  ข้อมูลยืนยันจาก query DB จริง  |  dbo = READ-ONLY  |  schema wf = สร้างใหม่</a:t>
             </a:r>
             <a:endParaRPr lang="en-US" sz="850" dirty="0"/>
           </a:p>
@@ -10364,7 +10364,7 @@
                 <a:latin typeface="Prompt"/>
                 <a:cs typeface="Prompt"/>
               </a:rPr>
-              <a:t>v6.1 Release — โมดูลใหม่ &amp; สถานะการพัฒนา</a:t>
+              <a:t>v6.2 Release — โมดูลใหม่ &amp; สถานะการพัฒนา</a:t>
             </a:r>
           </a:p>
         </p:txBody>
@@ -10719,7 +10719,7 @@
                 <a:latin typeface="Prompt"/>
                 <a:cs typeface="Prompt"/>
               </a:rPr>
-              <a:t>World Fert Co., Ltd. · WS-Sale-App v6.1 (Production) · dbo = READ-ONLY · เขียนเฉพาะ schema wf</a:t>
+              <a:t>World Fert Co., Ltd. · WS-Sale-App v6.2 (Production) · dbo = READ-ONLY · เขียนเฉพาะ schema wf</a:t>
             </a:r>
           </a:p>
         </p:txBody>
@@ -10831,7 +10831,7 @@
                 <a:latin typeface="Prompt"/>
                 <a:cs typeface="Prompt"/>
               </a:rPr>
-              <a:t>แยกระบบให้ชัดเจน ไม่ปะปนกัน — ยืนยันจากข้อมูลจริง (v6.1)</a:t>
+              <a:t>แยกระบบให้ชัดเจน ไม่ปะปนกัน — ยืนยันจากข้อมูลจริง (v6.2)</a:t>
             </a:r>
           </a:p>
         </p:txBody>
@@ -11406,7 +11406,7 @@
                 <a:latin typeface="Prompt"/>
                 <a:cs typeface="Prompt"/>
               </a:rPr>
-              <a:t>DESIGN · เลื่อนจาก Phase 2 เข้า v6 · อิง db_truckscale (MySQL · 192.168.1.253)</a:t>
+              <a:t>LIVE (v4.2.17) · db_truckscale บน Railway MySQL · match ด้วยทะเบียนรถ</a:t>
             </a:r>
           </a:p>
         </p:txBody>
@@ -11797,7 +11797,7 @@
                 <a:latin typeface="Prompt"/>
                 <a:cs typeface="Prompt"/>
               </a:rPr>
-              <a:t>เชื่อมผ่าน naming convention — ยืนยันจากข้อมูลจริง (v6 DESIGN)</a:t>
+              <a:t>เชื่อมผ่านทะเบียนรถ — LIVE (v4.2.17 · Railway MySQL)</a:t>
             </a:r>
           </a:p>
         </p:txBody>
@@ -12348,7 +12348,7 @@
                 <a:latin typeface="Prompt"/>
                 <a:cs typeface="Prompt"/>
               </a:rPr>
-              <a:t>⏳ B4c — TruckScale live (รอ VPN 192.168.1.253)</a:t>
+              <a:t>✓ B4c — TruckScale LIVE (Railway MySQL)</a:t>
             </a:r>
           </a:p>
         </p:txBody>
@@ -12508,7 +12508,7 @@
                 <a:latin typeface="Prompt"/>
                 <a:cs typeface="Prompt"/>
               </a:rPr>
-              <a:t>คงเหลือ: TruckScale live (รอ VPN) · รายละเอียดอ้างอิง SRS v6.1 §17 (Implementation Update)</a:t>
+              <a:t>TruckScale: LIVE แล้ว (Railway MySQL) · รายละเอียดอ้างอิง SRS v6.2 §17 (Implementation Update)</a:t>
             </a:r>
           </a:p>
         </p:txBody>
@@ -17794,7 +17794,7 @@
                 <a:ea typeface="Prompt" pitchFamily="34" charset="-122"/>
                 <a:cs typeface="Prompt" pitchFamily="34" charset="-120"/>
               </a:rPr>
-              <a:t>UI/UX Design System — Light Theme Standard v6.1</a:t>
+              <a:t>UI/UX Design System — Light Theme Standard v6.2</a:t>
             </a:r>
             <a:endParaRPr lang="en-US" sz="1300" dirty="0"/>
           </a:p>

</xml_diff>